<commit_message>
:zap: mejoramiento de front-end con el back-end
</commit_message>
<xml_diff>
--- a/DOC/AcademicFlow-v10.pptx
+++ b/DOC/AcademicFlow-v10.pptx
@@ -3061,7 +3061,7 @@
                 <a:ea typeface="Inter Bold" pitchFamily="34" charset="-122"/>
                 <a:cs typeface="Inter Bold" pitchFamily="34" charset="-120"/>
               </a:rPr>
-              <a:t>8.2</a:t>
+              <a:t>8.5</a:t>
             </a:r>
             <a:endParaRPr lang="en-US" sz="2400" dirty="0"/>
           </a:p>
@@ -3708,7 +3708,7 @@
         </p:nvSpPr>
         <p:spPr>
           <a:xfrm>
-            <a:off x="800137" y="2301966"/>
+            <a:off x="823391" y="1517585"/>
             <a:ext cx="4114726" cy="290736"/>
           </a:xfrm>
           <a:prstGeom prst="rect">
@@ -3801,7 +3801,7 @@
         </p:nvSpPr>
         <p:spPr>
           <a:xfrm>
-            <a:off x="325562" y="2671911"/>
+            <a:off x="348816" y="1792911"/>
             <a:ext cx="5063877" cy="307032"/>
           </a:xfrm>
           <a:prstGeom prst="rect">
@@ -3871,6 +3871,101 @@
           <a:lstStyle/>
           <a:p>
             <a:endParaRPr lang="es-419"/>
+          </a:p>
+        </p:txBody>
+      </p:sp>
+      <p:sp>
+        <p:nvSpPr>
+          <p:cNvPr id="7" name="Text 10">
+            <a:extLst>
+              <a:ext uri="{FF2B5EF4-FFF2-40B4-BE49-F238E27FC236}">
+                <a16:creationId xmlns:a16="http://schemas.microsoft.com/office/drawing/2014/main" id="{197DC5AF-E245-AB2D-617E-BD03B275EDDA}"/>
+              </a:ext>
+            </a:extLst>
+          </p:cNvPr>
+          <p:cNvSpPr/>
+          <p:nvPr/>
+        </p:nvSpPr>
+        <p:spPr>
+          <a:xfrm>
+            <a:off x="433058" y="2924173"/>
+            <a:ext cx="5063877" cy="307032"/>
+          </a:xfrm>
+          <a:prstGeom prst="rect">
+            <a:avLst/>
+          </a:prstGeom>
+          <a:noFill/>
+          <a:ln/>
+        </p:spPr>
+        <p:txBody>
+          <a:bodyPr wrap="none" lIns="0" tIns="0" rIns="0" bIns="0" rtlCol="0" anchor="t"/>
+          <a:lstStyle/>
+          <a:p>
+            <a:pPr algn="ctr">
+              <a:lnSpc>
+                <a:spcPct val="83000"/>
+              </a:lnSpc>
+            </a:pPr>
+            <a:r>
+              <a:rPr lang="en-US" sz="1000" dirty="0"/>
+              <a:t>https://drive.google.com/drive/folders/19ArpcFN7ufIe_ok2QW3Bgo5tq_Vtecy4?usp=sharing</a:t>
+            </a:r>
+          </a:p>
+        </p:txBody>
+      </p:sp>
+      <p:sp>
+        <p:nvSpPr>
+          <p:cNvPr id="8" name="Text 3">
+            <a:extLst>
+              <a:ext uri="{FF2B5EF4-FFF2-40B4-BE49-F238E27FC236}">
+                <a16:creationId xmlns:a16="http://schemas.microsoft.com/office/drawing/2014/main" id="{4403FC88-8F78-0C71-E7E0-F0927329128E}"/>
+              </a:ext>
+            </a:extLst>
+          </p:cNvPr>
+          <p:cNvSpPr/>
+          <p:nvPr/>
+        </p:nvSpPr>
+        <p:spPr>
+          <a:xfrm>
+            <a:off x="800136" y="2476953"/>
+            <a:ext cx="4114726" cy="290736"/>
+          </a:xfrm>
+          <a:prstGeom prst="rect">
+            <a:avLst/>
+          </a:prstGeom>
+          <a:noFill/>
+          <a:ln/>
+        </p:spPr>
+        <p:txBody>
+          <a:bodyPr wrap="none" lIns="0" tIns="0" rIns="0" bIns="0" rtlCol="0" anchor="t"/>
+          <a:lstStyle/>
+          <a:p>
+            <a:pPr marL="0" indent="0" algn="ctr">
+              <a:lnSpc>
+                <a:spcPct val="104000"/>
+              </a:lnSpc>
+              <a:buNone/>
+            </a:pPr>
+            <a:r>
+              <a:rPr lang="en-US" sz="1800" b="1" dirty="0">
+                <a:solidFill>
+                  <a:srgbClr val="000000"/>
+                </a:solidFill>
+                <a:latin typeface="Inter Bold" pitchFamily="34" charset="0"/>
+                <a:ea typeface="Inter Bold" pitchFamily="34" charset="-122"/>
+                <a:cs typeface="Inter Bold" pitchFamily="34" charset="-120"/>
+              </a:rPr>
+              <a:t>RECURSOS</a:t>
+            </a:r>
+          </a:p>
+          <a:p>
+            <a:pPr marL="0" indent="0" algn="ctr">
+              <a:lnSpc>
+                <a:spcPct val="104000"/>
+              </a:lnSpc>
+              <a:buNone/>
+            </a:pPr>
+            <a:endParaRPr lang="en-US" sz="1800" dirty="0"/>
           </a:p>
         </p:txBody>
       </p:sp>
@@ -8552,7 +8647,7 @@
                 <a:ea typeface="Inter Bold" pitchFamily="34" charset="-122"/>
                 <a:cs typeface="Inter Bold" pitchFamily="34" charset="-120"/>
               </a:rPr>
-              <a:t>7.6 / 10</a:t>
+              <a:t>8.5 / 10</a:t>
             </a:r>
             <a:endParaRPr lang="en-US" sz="3850" dirty="0"/>
           </a:p>
@@ -9043,7 +9138,7 @@
                 <a:ea typeface="Inter" pitchFamily="34" charset="-122"/>
                 <a:cs typeface="Inter" pitchFamily="34" charset="-120"/>
               </a:rPr>
-              <a:t>Autenticación robusta en la web app (JWT / IdP)</a:t>
+              <a:t>Autenticación robusta en la web app</a:t>
             </a:r>
             <a:endParaRPr lang="en-US" sz="1100" dirty="0"/>
           </a:p>

</xml_diff>